<commit_message>
Add live URL to deck (cover, contact, footers) + refresh slides
</commit_message>
<xml_diff>
--- a/Portofolio_Ali_Akbar_DataAnalyst.pptx
+++ b/Portofolio_Ali_Akbar_DataAnalyst.pptx
@@ -2917,31 +2917,52 @@
         <p:spPr>
           <a:xfrm>
             <a:off x="868680" y="6419088"/>
-            <a:ext cx="8229600" cy="274320"/>
-          </a:xfrm>
-          <a:prstGeom prst="rect">
-            <a:avLst/>
-          </a:prstGeom>
-          <a:noFill/>
-          <a:ln/>
-        </p:spPr>
-        <p:txBody>
-          <a:bodyPr wrap="square" lIns="0" tIns="0" rIns="0" bIns="0" rtlCol="0" anchor="ctr"/>
-          <a:lstStyle/>
-          <a:p>
-            <a:pPr indent="0" marL="0">
-              <a:buNone/>
-            </a:pPr>
-            <a:r>
-              <a:rPr lang="en-US" sz="1000" dirty="0">
-                <a:solidFill>
-                  <a:srgbClr val="5A6B7F"/>
+            <a:ext cx="10789920" cy="274320"/>
+          </a:xfrm>
+          <a:prstGeom prst="rect">
+            <a:avLst/>
+          </a:prstGeom>
+          <a:noFill/>
+          <a:ln/>
+        </p:spPr>
+        <p:txBody>
+          <a:bodyPr wrap="square" lIns="0" tIns="0" rIns="0" bIns="0" rtlCol="0" anchor="ctr"/>
+          <a:lstStyle/>
+          <a:p>
+            <a:pPr indent="0" marL="0">
+              <a:buNone/>
+            </a:pPr>
+            <a:r>
+              <a:rPr lang="en-US" sz="1000" b="1" u="sng" dirty="0">
+                <a:solidFill>
+                  <a:srgbClr val="34D399"/>
                 </a:solidFill>
                 <a:latin typeface="Courier New" pitchFamily="34" charset="0"/>
                 <a:ea typeface="Courier New" pitchFamily="34" charset="-122"/>
                 <a:cs typeface="Courier New" pitchFamily="34" charset="-120"/>
-              </a:rPr>
-              <a:t>akbaralqahri@gmail.com   ·   linkedin.com/in/akbaralqahri</a:t>
+                <a:hlinkClick r:id="rId2" invalidUrl="" action="" tgtFrame="" tooltip="" history="1" highlightClick="0" endSnd="0">
+                  <a:extLst>
+                    <a:ext uri="{A12FA001-AC4F-418D-AE19-62706E023703}">
+                      <ahyp:hlinkClr xmlns:ahyp="http://schemas.microsoft.com/office/drawing/2018/hyperlinkcolor" val="tx"/>
+                    </a:ext>
+                  </a:extLst>
+                </a:hlinkClick>
+              </a:rPr>
+              <a:t>🌐 maganghubportofolio.vercel.app</a:t>
+            </a:r>
+            <a:pPr indent="0" marL="0">
+              <a:buNone/>
+            </a:pPr>
+            <a:r>
+              <a:rPr lang="en-US" sz="1000" dirty="0">
+                <a:solidFill>
+                  <a:srgbClr val="5A6B7F"/>
+                </a:solidFill>
+                <a:latin typeface="Courier New" pitchFamily="34" charset="0"/>
+                <a:ea typeface="Courier New" pitchFamily="34" charset="-122"/>
+                <a:cs typeface="Courier New" pitchFamily="34" charset="-120"/>
+              </a:rPr>
+              <a:t>      ·      akbaralqahri@gmail.com      ·      linkedin.com/in/akbaralqahri</a:t>
             </a:r>
             <a:endParaRPr lang="en-US" sz="1000" dirty="0"/>
           </a:p>
@@ -3456,7 +3477,110 @@
       </p:sp>
       <p:sp>
         <p:nvSpPr>
-          <p:cNvPr id="15" name="Text 13"/>
+          <p:cNvPr id="15" name="Shape 13"/>
+          <p:cNvSpPr/>
+          <p:nvPr/>
+        </p:nvSpPr>
+        <p:spPr>
+          <a:xfrm>
+            <a:off x="548640" y="5349240"/>
+            <a:ext cx="6766560" cy="658368"/>
+          </a:xfrm>
+          <a:prstGeom prst="roundRect">
+            <a:avLst>
+              <a:gd name="adj" fmla="val 16667"/>
+            </a:avLst>
+          </a:prstGeom>
+          <a:solidFill>
+            <a:srgbClr val="059669"/>
+          </a:solidFill>
+          <a:ln w="19050">
+            <a:solidFill>
+              <a:srgbClr val="34D399"/>
+            </a:solidFill>
+            <a:prstDash val="solid"/>
+          </a:ln>
+          <a:effectLst>
+            <a:outerShdw sx="100000" sy="100000" kx="0" ky="0" algn="bl" rotWithShape="0" blurRad="152400" dist="38100" dir="5400000">
+              <a:srgbClr val="000000">
+                <a:alpha val="45000"/>
+              </a:srgbClr>
+            </a:outerShdw>
+          </a:effectLst>
+        </p:spPr>
+      </p:sp>
+      <p:sp>
+        <p:nvSpPr>
+          <p:cNvPr id="16" name="Text 14">
+            <a:hlinkClick r:id="rIdundefined" tooltip=""/>
+          </p:cNvPr>
+          <p:cNvSpPr/>
+          <p:nvPr/>
+        </p:nvSpPr>
+        <p:spPr>
+          <a:xfrm>
+            <a:off x="548640" y="5349240"/>
+            <a:ext cx="6766560" cy="658368"/>
+          </a:xfrm>
+          <a:prstGeom prst="rect">
+            <a:avLst/>
+          </a:prstGeom>
+          <a:noFill/>
+          <a:ln/>
+        </p:spPr>
+        <p:txBody>
+          <a:bodyPr wrap="square" lIns="0" tIns="0" rIns="0" bIns="0" rtlCol="0" anchor="ctr"/>
+          <a:lstStyle/>
+          <a:p>
+            <a:pPr algn="ctr" indent="0" marL="0">
+              <a:buNone/>
+            </a:pPr>
+            <a:r>
+              <a:rPr lang="en-US" sz="1300" u="sng" dirty="0">
+                <a:solidFill>
+                  <a:srgbClr val="EAFFF5"/>
+                </a:solidFill>
+                <a:latin typeface="Courier New" pitchFamily="34" charset="0"/>
+                <a:ea typeface="Courier New" pitchFamily="34" charset="-122"/>
+                <a:cs typeface="Courier New" pitchFamily="34" charset="-120"/>
+                <a:hlinkClick r:id="rIdundefined" invalidUrl="" action="" tgtFrame="" tooltip="" history="1" highlightClick="0" endSnd="0">
+                  <a:extLst>
+                    <a:ext uri="{A12FA001-AC4F-418D-AE19-62706E023703}">
+                      <ahyp:hlinkClr xmlns:ahyp="http://schemas.microsoft.com/office/drawing/2018/hyperlinkcolor" val="tx"/>
+                    </a:ext>
+                  </a:extLst>
+                </a:hlinkClick>
+              </a:rPr>
+              <a:t>🌐  Live portfolio  —  </a:t>
+            </a:r>
+            <a:pPr algn="ctr" indent="0" marL="0">
+              <a:buNone/>
+            </a:pPr>
+            <a:r>
+              <a:rPr lang="en-US" sz="1300" b="1" u="sng" dirty="0">
+                <a:solidFill>
+                  <a:srgbClr val="FFFFFF"/>
+                </a:solidFill>
+                <a:latin typeface="Courier New" pitchFamily="34" charset="0"/>
+                <a:ea typeface="Courier New" pitchFamily="34" charset="-122"/>
+                <a:cs typeface="Courier New" pitchFamily="34" charset="-120"/>
+                <a:hlinkClick r:id="rIdundefined" invalidUrl="" action="" tgtFrame="" tooltip="" history="1" highlightClick="0" endSnd="0">
+                  <a:extLst>
+                    <a:ext uri="{A12FA001-AC4F-418D-AE19-62706E023703}">
+                      <ahyp:hlinkClr xmlns:ahyp="http://schemas.microsoft.com/office/drawing/2018/hyperlinkcolor" val="tx"/>
+                    </a:ext>
+                  </a:extLst>
+                </a:hlinkClick>
+              </a:rPr>
+              <a:t>maganghubportofolio.vercel.app</a:t>
+            </a:r>
+            <a:endParaRPr lang="en-US" sz="1300" dirty="0"/>
+          </a:p>
+        </p:txBody>
+      </p:sp>
+      <p:sp>
+        <p:nvSpPr>
+          <p:cNvPr id="17" name="Text 15"/>
           <p:cNvSpPr/>
           <p:nvPr/>
         </p:nvSpPr>
@@ -4408,38 +4532,47 @@
       </p:sp>
       <p:sp>
         <p:nvSpPr>
-          <p:cNvPr id="26" name="Text 24"/>
+          <p:cNvPr id="26" name="Text 24">
+            <a:hlinkClick r:id="rId1" tooltip=""/>
+          </p:cNvPr>
           <p:cNvSpPr/>
           <p:nvPr/>
         </p:nvSpPr>
         <p:spPr>
           <a:xfrm>
             <a:off x="548640" y="6446520"/>
-            <a:ext cx="5486400" cy="274320"/>
-          </a:xfrm>
-          <a:prstGeom prst="rect">
-            <a:avLst/>
-          </a:prstGeom>
-          <a:noFill/>
-          <a:ln/>
-        </p:spPr>
-        <p:txBody>
-          <a:bodyPr wrap="square" lIns="0" tIns="0" rIns="0" bIns="0" rtlCol="0" anchor="ctr"/>
-          <a:lstStyle/>
-          <a:p>
-            <a:pPr indent="0" marL="0">
-              <a:buNone/>
-            </a:pPr>
-            <a:r>
-              <a:rPr lang="en-US" sz="900" dirty="0">
+            <a:ext cx="5943600" cy="274320"/>
+          </a:xfrm>
+          <a:prstGeom prst="rect">
+            <a:avLst/>
+          </a:prstGeom>
+          <a:noFill/>
+          <a:ln/>
+        </p:spPr>
+        <p:txBody>
+          <a:bodyPr wrap="square" lIns="0" tIns="0" rIns="0" bIns="0" rtlCol="0" anchor="ctr"/>
+          <a:lstStyle/>
+          <a:p>
+            <a:pPr indent="0" marL="0">
+              <a:buNone/>
+            </a:pPr>
+            <a:r>
+              <a:rPr lang="en-US" sz="900" u="sng" dirty="0">
                 <a:solidFill>
                   <a:srgbClr val="5A6B7F"/>
                 </a:solidFill>
                 <a:latin typeface="Courier New" pitchFamily="34" charset="0"/>
                 <a:ea typeface="Courier New" pitchFamily="34" charset="-122"/>
                 <a:cs typeface="Courier New" pitchFamily="34" charset="-120"/>
-              </a:rPr>
-              <a:t>ali.akbar_  //  Data Analyst</a:t>
+                <a:hlinkClick r:id="rId1" invalidUrl="" action="" tgtFrame="" tooltip="" history="1" highlightClick="0" endSnd="0">
+                  <a:extLst>
+                    <a:ext uri="{A12FA001-AC4F-418D-AE19-62706E023703}">
+                      <ahyp:hlinkClr xmlns:ahyp="http://schemas.microsoft.com/office/drawing/2018/hyperlinkcolor" val="tx"/>
+                    </a:ext>
+                  </a:extLst>
+                </a:hlinkClick>
+              </a:rPr>
+              <a:t>↗ maganghubportofolio.vercel.app</a:t>
             </a:r>
             <a:endParaRPr lang="en-US" sz="900" dirty="0"/>
           </a:p>
@@ -5095,38 +5228,47 @@
       </p:sp>
       <p:sp>
         <p:nvSpPr>
-          <p:cNvPr id="17" name="Text 15"/>
+          <p:cNvPr id="17" name="Text 15">
+            <a:hlinkClick r:id="rId1" tooltip=""/>
+          </p:cNvPr>
           <p:cNvSpPr/>
           <p:nvPr/>
         </p:nvSpPr>
         <p:spPr>
           <a:xfrm>
             <a:off x="548640" y="6446520"/>
-            <a:ext cx="5486400" cy="274320"/>
-          </a:xfrm>
-          <a:prstGeom prst="rect">
-            <a:avLst/>
-          </a:prstGeom>
-          <a:noFill/>
-          <a:ln/>
-        </p:spPr>
-        <p:txBody>
-          <a:bodyPr wrap="square" lIns="0" tIns="0" rIns="0" bIns="0" rtlCol="0" anchor="ctr"/>
-          <a:lstStyle/>
-          <a:p>
-            <a:pPr indent="0" marL="0">
-              <a:buNone/>
-            </a:pPr>
-            <a:r>
-              <a:rPr lang="en-US" sz="900" dirty="0">
+            <a:ext cx="5943600" cy="274320"/>
+          </a:xfrm>
+          <a:prstGeom prst="rect">
+            <a:avLst/>
+          </a:prstGeom>
+          <a:noFill/>
+          <a:ln/>
+        </p:spPr>
+        <p:txBody>
+          <a:bodyPr wrap="square" lIns="0" tIns="0" rIns="0" bIns="0" rtlCol="0" anchor="ctr"/>
+          <a:lstStyle/>
+          <a:p>
+            <a:pPr indent="0" marL="0">
+              <a:buNone/>
+            </a:pPr>
+            <a:r>
+              <a:rPr lang="en-US" sz="900" u="sng" dirty="0">
                 <a:solidFill>
                   <a:srgbClr val="5A6B7F"/>
                 </a:solidFill>
                 <a:latin typeface="Courier New" pitchFamily="34" charset="0"/>
                 <a:ea typeface="Courier New" pitchFamily="34" charset="-122"/>
                 <a:cs typeface="Courier New" pitchFamily="34" charset="-120"/>
-              </a:rPr>
-              <a:t>ali.akbar_  //  Data Analyst</a:t>
+                <a:hlinkClick r:id="rId1" invalidUrl="" action="" tgtFrame="" tooltip="" history="1" highlightClick="0" endSnd="0">
+                  <a:extLst>
+                    <a:ext uri="{A12FA001-AC4F-418D-AE19-62706E023703}">
+                      <ahyp:hlinkClr xmlns:ahyp="http://schemas.microsoft.com/office/drawing/2018/hyperlinkcolor" val="tx"/>
+                    </a:ext>
+                  </a:extLst>
+                </a:hlinkClick>
+              </a:rPr>
+              <a:t>↗ maganghubportofolio.vercel.app</a:t>
             </a:r>
             <a:endParaRPr lang="en-US" sz="900" dirty="0"/>
           </a:p>
@@ -6173,38 +6315,47 @@
       </p:sp>
       <p:sp>
         <p:nvSpPr>
-          <p:cNvPr id="24" name="Text 22"/>
+          <p:cNvPr id="24" name="Text 22">
+            <a:hlinkClick r:id="rId1" tooltip=""/>
+          </p:cNvPr>
           <p:cNvSpPr/>
           <p:nvPr/>
         </p:nvSpPr>
         <p:spPr>
           <a:xfrm>
             <a:off x="548640" y="6446520"/>
-            <a:ext cx="5486400" cy="274320"/>
-          </a:xfrm>
-          <a:prstGeom prst="rect">
-            <a:avLst/>
-          </a:prstGeom>
-          <a:noFill/>
-          <a:ln/>
-        </p:spPr>
-        <p:txBody>
-          <a:bodyPr wrap="square" lIns="0" tIns="0" rIns="0" bIns="0" rtlCol="0" anchor="ctr"/>
-          <a:lstStyle/>
-          <a:p>
-            <a:pPr indent="0" marL="0">
-              <a:buNone/>
-            </a:pPr>
-            <a:r>
-              <a:rPr lang="en-US" sz="900" dirty="0">
+            <a:ext cx="5943600" cy="274320"/>
+          </a:xfrm>
+          <a:prstGeom prst="rect">
+            <a:avLst/>
+          </a:prstGeom>
+          <a:noFill/>
+          <a:ln/>
+        </p:spPr>
+        <p:txBody>
+          <a:bodyPr wrap="square" lIns="0" tIns="0" rIns="0" bIns="0" rtlCol="0" anchor="ctr"/>
+          <a:lstStyle/>
+          <a:p>
+            <a:pPr indent="0" marL="0">
+              <a:buNone/>
+            </a:pPr>
+            <a:r>
+              <a:rPr lang="en-US" sz="900" u="sng" dirty="0">
                 <a:solidFill>
                   <a:srgbClr val="5A6B7F"/>
                 </a:solidFill>
                 <a:latin typeface="Courier New" pitchFamily="34" charset="0"/>
                 <a:ea typeface="Courier New" pitchFamily="34" charset="-122"/>
                 <a:cs typeface="Courier New" pitchFamily="34" charset="-120"/>
-              </a:rPr>
-              <a:t>ali.akbar_  //  Data Analyst</a:t>
+                <a:hlinkClick r:id="rId1" invalidUrl="" action="" tgtFrame="" tooltip="" history="1" highlightClick="0" endSnd="0">
+                  <a:extLst>
+                    <a:ext uri="{A12FA001-AC4F-418D-AE19-62706E023703}">
+                      <ahyp:hlinkClr xmlns:ahyp="http://schemas.microsoft.com/office/drawing/2018/hyperlinkcolor" val="tx"/>
+                    </a:ext>
+                  </a:extLst>
+                </a:hlinkClick>
+              </a:rPr>
+              <a:t>↗ maganghubportofolio.vercel.app</a:t>
             </a:r>
             <a:endParaRPr lang="en-US" sz="900" dirty="0"/>
           </a:p>
@@ -7658,38 +7809,47 @@
       </p:sp>
       <p:sp>
         <p:nvSpPr>
-          <p:cNvPr id="39" name="Text 37"/>
+          <p:cNvPr id="39" name="Text 37">
+            <a:hlinkClick r:id="rId1" tooltip=""/>
+          </p:cNvPr>
           <p:cNvSpPr/>
           <p:nvPr/>
         </p:nvSpPr>
         <p:spPr>
           <a:xfrm>
             <a:off x="548640" y="6446520"/>
-            <a:ext cx="5486400" cy="274320"/>
-          </a:xfrm>
-          <a:prstGeom prst="rect">
-            <a:avLst/>
-          </a:prstGeom>
-          <a:noFill/>
-          <a:ln/>
-        </p:spPr>
-        <p:txBody>
-          <a:bodyPr wrap="square" lIns="0" tIns="0" rIns="0" bIns="0" rtlCol="0" anchor="ctr"/>
-          <a:lstStyle/>
-          <a:p>
-            <a:pPr indent="0" marL="0">
-              <a:buNone/>
-            </a:pPr>
-            <a:r>
-              <a:rPr lang="en-US" sz="900" dirty="0">
+            <a:ext cx="5943600" cy="274320"/>
+          </a:xfrm>
+          <a:prstGeom prst="rect">
+            <a:avLst/>
+          </a:prstGeom>
+          <a:noFill/>
+          <a:ln/>
+        </p:spPr>
+        <p:txBody>
+          <a:bodyPr wrap="square" lIns="0" tIns="0" rIns="0" bIns="0" rtlCol="0" anchor="ctr"/>
+          <a:lstStyle/>
+          <a:p>
+            <a:pPr indent="0" marL="0">
+              <a:buNone/>
+            </a:pPr>
+            <a:r>
+              <a:rPr lang="en-US" sz="900" u="sng" dirty="0">
                 <a:solidFill>
                   <a:srgbClr val="5A6B7F"/>
                 </a:solidFill>
                 <a:latin typeface="Courier New" pitchFamily="34" charset="0"/>
                 <a:ea typeface="Courier New" pitchFamily="34" charset="-122"/>
                 <a:cs typeface="Courier New" pitchFamily="34" charset="-120"/>
-              </a:rPr>
-              <a:t>ali.akbar_  //  Data Analyst</a:t>
+                <a:hlinkClick r:id="rId1" invalidUrl="" action="" tgtFrame="" tooltip="" history="1" highlightClick="0" endSnd="0">
+                  <a:extLst>
+                    <a:ext uri="{A12FA001-AC4F-418D-AE19-62706E023703}">
+                      <ahyp:hlinkClr xmlns:ahyp="http://schemas.microsoft.com/office/drawing/2018/hyperlinkcolor" val="tx"/>
+                    </a:ext>
+                  </a:extLst>
+                </a:hlinkClick>
+              </a:rPr>
+              <a:t>↗ maganghubportofolio.vercel.app</a:t>
             </a:r>
             <a:endParaRPr lang="en-US" sz="900" dirty="0"/>
           </a:p>
@@ -8386,38 +8546,47 @@
       </p:sp>
       <p:sp>
         <p:nvSpPr>
-          <p:cNvPr id="20" name="Text 14"/>
+          <p:cNvPr id="20" name="Text 14">
+            <a:hlinkClick r:id="rId5" tooltip=""/>
+          </p:cNvPr>
           <p:cNvSpPr/>
           <p:nvPr/>
         </p:nvSpPr>
         <p:spPr>
           <a:xfrm>
             <a:off x="548640" y="6446520"/>
-            <a:ext cx="5486400" cy="274320"/>
-          </a:xfrm>
-          <a:prstGeom prst="rect">
-            <a:avLst/>
-          </a:prstGeom>
-          <a:noFill/>
-          <a:ln/>
-        </p:spPr>
-        <p:txBody>
-          <a:bodyPr wrap="square" lIns="0" tIns="0" rIns="0" bIns="0" rtlCol="0" anchor="ctr"/>
-          <a:lstStyle/>
-          <a:p>
-            <a:pPr indent="0" marL="0">
-              <a:buNone/>
-            </a:pPr>
-            <a:r>
-              <a:rPr lang="en-US" sz="900" dirty="0">
+            <a:ext cx="5943600" cy="274320"/>
+          </a:xfrm>
+          <a:prstGeom prst="rect">
+            <a:avLst/>
+          </a:prstGeom>
+          <a:noFill/>
+          <a:ln/>
+        </p:spPr>
+        <p:txBody>
+          <a:bodyPr wrap="square" lIns="0" tIns="0" rIns="0" bIns="0" rtlCol="0" anchor="ctr"/>
+          <a:lstStyle/>
+          <a:p>
+            <a:pPr indent="0" marL="0">
+              <a:buNone/>
+            </a:pPr>
+            <a:r>
+              <a:rPr lang="en-US" sz="900" u="sng" dirty="0">
                 <a:solidFill>
                   <a:srgbClr val="5A6B7F"/>
                 </a:solidFill>
                 <a:latin typeface="Courier New" pitchFamily="34" charset="0"/>
                 <a:ea typeface="Courier New" pitchFamily="34" charset="-122"/>
                 <a:cs typeface="Courier New" pitchFamily="34" charset="-120"/>
-              </a:rPr>
-              <a:t>ali.akbar_  //  Data Analyst</a:t>
+                <a:hlinkClick r:id="rId5" invalidUrl="" action="" tgtFrame="" tooltip="" history="1" highlightClick="0" endSnd="0">
+                  <a:extLst>
+                    <a:ext uri="{A12FA001-AC4F-418D-AE19-62706E023703}">
+                      <ahyp:hlinkClr xmlns:ahyp="http://schemas.microsoft.com/office/drawing/2018/hyperlinkcolor" val="tx"/>
+                    </a:ext>
+                  </a:extLst>
+                </a:hlinkClick>
+              </a:rPr>
+              <a:t>↗ maganghubportofolio.vercel.app</a:t>
             </a:r>
             <a:endParaRPr lang="en-US" sz="900" dirty="0"/>
           </a:p>
@@ -9407,38 +9576,47 @@
       </p:sp>
       <p:sp>
         <p:nvSpPr>
-          <p:cNvPr id="26" name="Text 22"/>
+          <p:cNvPr id="26" name="Text 22">
+            <a:hlinkClick r:id="rId3" tooltip=""/>
+          </p:cNvPr>
           <p:cNvSpPr/>
           <p:nvPr/>
         </p:nvSpPr>
         <p:spPr>
           <a:xfrm>
             <a:off x="548640" y="6446520"/>
-            <a:ext cx="5486400" cy="274320"/>
-          </a:xfrm>
-          <a:prstGeom prst="rect">
-            <a:avLst/>
-          </a:prstGeom>
-          <a:noFill/>
-          <a:ln/>
-        </p:spPr>
-        <p:txBody>
-          <a:bodyPr wrap="square" lIns="0" tIns="0" rIns="0" bIns="0" rtlCol="0" anchor="ctr"/>
-          <a:lstStyle/>
-          <a:p>
-            <a:pPr indent="0" marL="0">
-              <a:buNone/>
-            </a:pPr>
-            <a:r>
-              <a:rPr lang="en-US" sz="900" dirty="0">
+            <a:ext cx="5943600" cy="274320"/>
+          </a:xfrm>
+          <a:prstGeom prst="rect">
+            <a:avLst/>
+          </a:prstGeom>
+          <a:noFill/>
+          <a:ln/>
+        </p:spPr>
+        <p:txBody>
+          <a:bodyPr wrap="square" lIns="0" tIns="0" rIns="0" bIns="0" rtlCol="0" anchor="ctr"/>
+          <a:lstStyle/>
+          <a:p>
+            <a:pPr indent="0" marL="0">
+              <a:buNone/>
+            </a:pPr>
+            <a:r>
+              <a:rPr lang="en-US" sz="900" u="sng" dirty="0">
                 <a:solidFill>
                   <a:srgbClr val="5A6B7F"/>
                 </a:solidFill>
                 <a:latin typeface="Courier New" pitchFamily="34" charset="0"/>
                 <a:ea typeface="Courier New" pitchFamily="34" charset="-122"/>
                 <a:cs typeface="Courier New" pitchFamily="34" charset="-120"/>
-              </a:rPr>
-              <a:t>ali.akbar_  //  Data Analyst</a:t>
+                <a:hlinkClick r:id="rId3" invalidUrl="" action="" tgtFrame="" tooltip="" history="1" highlightClick="0" endSnd="0">
+                  <a:extLst>
+                    <a:ext uri="{A12FA001-AC4F-418D-AE19-62706E023703}">
+                      <ahyp:hlinkClr xmlns:ahyp="http://schemas.microsoft.com/office/drawing/2018/hyperlinkcolor" val="tx"/>
+                    </a:ext>
+                  </a:extLst>
+                </a:hlinkClick>
+              </a:rPr>
+              <a:t>↗ maganghubportofolio.vercel.app</a:t>
             </a:r>
             <a:endParaRPr lang="en-US" sz="900" dirty="0"/>
           </a:p>
@@ -10501,38 +10679,47 @@
       </p:sp>
       <p:sp>
         <p:nvSpPr>
-          <p:cNvPr id="28" name="Text 26"/>
+          <p:cNvPr id="28" name="Text 26">
+            <a:hlinkClick r:id="rId1" tooltip=""/>
+          </p:cNvPr>
           <p:cNvSpPr/>
           <p:nvPr/>
         </p:nvSpPr>
         <p:spPr>
           <a:xfrm>
             <a:off x="548640" y="6446520"/>
-            <a:ext cx="5486400" cy="274320"/>
-          </a:xfrm>
-          <a:prstGeom prst="rect">
-            <a:avLst/>
-          </a:prstGeom>
-          <a:noFill/>
-          <a:ln/>
-        </p:spPr>
-        <p:txBody>
-          <a:bodyPr wrap="square" lIns="0" tIns="0" rIns="0" bIns="0" rtlCol="0" anchor="ctr"/>
-          <a:lstStyle/>
-          <a:p>
-            <a:pPr indent="0" marL="0">
-              <a:buNone/>
-            </a:pPr>
-            <a:r>
-              <a:rPr lang="en-US" sz="900" dirty="0">
+            <a:ext cx="5943600" cy="274320"/>
+          </a:xfrm>
+          <a:prstGeom prst="rect">
+            <a:avLst/>
+          </a:prstGeom>
+          <a:noFill/>
+          <a:ln/>
+        </p:spPr>
+        <p:txBody>
+          <a:bodyPr wrap="square" lIns="0" tIns="0" rIns="0" bIns="0" rtlCol="0" anchor="ctr"/>
+          <a:lstStyle/>
+          <a:p>
+            <a:pPr indent="0" marL="0">
+              <a:buNone/>
+            </a:pPr>
+            <a:r>
+              <a:rPr lang="en-US" sz="900" u="sng" dirty="0">
                 <a:solidFill>
                   <a:srgbClr val="5A6B7F"/>
                 </a:solidFill>
                 <a:latin typeface="Courier New" pitchFamily="34" charset="0"/>
                 <a:ea typeface="Courier New" pitchFamily="34" charset="-122"/>
                 <a:cs typeface="Courier New" pitchFamily="34" charset="-120"/>
-              </a:rPr>
-              <a:t>ali.akbar_  //  Data Analyst</a:t>
+                <a:hlinkClick r:id="rId1" invalidUrl="" action="" tgtFrame="" tooltip="" history="1" highlightClick="0" endSnd="0">
+                  <a:extLst>
+                    <a:ext uri="{A12FA001-AC4F-418D-AE19-62706E023703}">
+                      <ahyp:hlinkClr xmlns:ahyp="http://schemas.microsoft.com/office/drawing/2018/hyperlinkcolor" val="tx"/>
+                    </a:ext>
+                  </a:extLst>
+                </a:hlinkClick>
+              </a:rPr>
+              <a:t>↗ maganghubportofolio.vercel.app</a:t>
             </a:r>
             <a:endParaRPr lang="en-US" sz="900" dirty="0"/>
           </a:p>
@@ -11436,38 +11623,47 @@
       </p:sp>
       <p:sp>
         <p:nvSpPr>
-          <p:cNvPr id="25" name="Text 23"/>
+          <p:cNvPr id="25" name="Text 23">
+            <a:hlinkClick r:id="rId1" tooltip=""/>
+          </p:cNvPr>
           <p:cNvSpPr/>
           <p:nvPr/>
         </p:nvSpPr>
         <p:spPr>
           <a:xfrm>
             <a:off x="548640" y="6446520"/>
-            <a:ext cx="5486400" cy="274320"/>
-          </a:xfrm>
-          <a:prstGeom prst="rect">
-            <a:avLst/>
-          </a:prstGeom>
-          <a:noFill/>
-          <a:ln/>
-        </p:spPr>
-        <p:txBody>
-          <a:bodyPr wrap="square" lIns="0" tIns="0" rIns="0" bIns="0" rtlCol="0" anchor="ctr"/>
-          <a:lstStyle/>
-          <a:p>
-            <a:pPr indent="0" marL="0">
-              <a:buNone/>
-            </a:pPr>
-            <a:r>
-              <a:rPr lang="en-US" sz="900" dirty="0">
+            <a:ext cx="5943600" cy="274320"/>
+          </a:xfrm>
+          <a:prstGeom prst="rect">
+            <a:avLst/>
+          </a:prstGeom>
+          <a:noFill/>
+          <a:ln/>
+        </p:spPr>
+        <p:txBody>
+          <a:bodyPr wrap="square" lIns="0" tIns="0" rIns="0" bIns="0" rtlCol="0" anchor="ctr"/>
+          <a:lstStyle/>
+          <a:p>
+            <a:pPr indent="0" marL="0">
+              <a:buNone/>
+            </a:pPr>
+            <a:r>
+              <a:rPr lang="en-US" sz="900" u="sng" dirty="0">
                 <a:solidFill>
                   <a:srgbClr val="5A6B7F"/>
                 </a:solidFill>
                 <a:latin typeface="Courier New" pitchFamily="34" charset="0"/>
                 <a:ea typeface="Courier New" pitchFamily="34" charset="-122"/>
                 <a:cs typeface="Courier New" pitchFamily="34" charset="-120"/>
-              </a:rPr>
-              <a:t>ali.akbar_  //  Data Analyst</a:t>
+                <a:hlinkClick r:id="rId1" invalidUrl="" action="" tgtFrame="" tooltip="" history="1" highlightClick="0" endSnd="0">
+                  <a:extLst>
+                    <a:ext uri="{A12FA001-AC4F-418D-AE19-62706E023703}">
+                      <ahyp:hlinkClr xmlns:ahyp="http://schemas.microsoft.com/office/drawing/2018/hyperlinkcolor" val="tx"/>
+                    </a:ext>
+                  </a:extLst>
+                </a:hlinkClick>
+              </a:rPr>
+              <a:t>↗ maganghubportofolio.vercel.app</a:t>
             </a:r>
             <a:endParaRPr lang="en-US" sz="900" dirty="0"/>
           </a:p>

</xml_diff>

<commit_message>
Blur confidential dashboards + generalize captions
</commit_message>
<xml_diff>
--- a/Portofolio_Ali_Akbar_DataAnalyst.pptx
+++ b/Portofolio_Ali_Akbar_DataAnalyst.pptx
@@ -7973,24 +7973,24 @@
         </p:nvSpPr>
         <p:spPr>
           <a:xfrm>
-            <a:off x="548640" y="822960"/>
-            <a:ext cx="10058400" cy="548640"/>
-          </a:xfrm>
-          <a:prstGeom prst="rect">
-            <a:avLst/>
-          </a:prstGeom>
-          <a:noFill/>
-          <a:ln/>
-        </p:spPr>
-        <p:txBody>
-          <a:bodyPr wrap="square" lIns="0" tIns="0" rIns="0" bIns="0" rtlCol="0" anchor="ctr"/>
-          <a:lstStyle/>
-          <a:p>
-            <a:pPr indent="0" marL="0">
-              <a:buNone/>
-            </a:pPr>
-            <a:r>
-              <a:rPr lang="en-US" sz="2800" b="1" dirty="0">
+            <a:off x="548640" y="749808"/>
+            <a:ext cx="10058400" cy="502920"/>
+          </a:xfrm>
+          <a:prstGeom prst="rect">
+            <a:avLst/>
+          </a:prstGeom>
+          <a:noFill/>
+          <a:ln/>
+        </p:spPr>
+        <p:txBody>
+          <a:bodyPr wrap="square" lIns="0" tIns="0" rIns="0" bIns="0" rtlCol="0" anchor="ctr"/>
+          <a:lstStyle/>
+          <a:p>
+            <a:pPr indent="0" marL="0">
+              <a:buNone/>
+            </a:pPr>
+            <a:r>
+              <a:rPr lang="en-US" sz="2600" b="1" dirty="0">
                 <a:solidFill>
                   <a:srgbClr val="E6EDF3"/>
                 </a:solidFill>
@@ -8000,13 +8000,52 @@
               </a:rPr>
               <a:t>Dashboard showcase — Power BI</a:t>
             </a:r>
-            <a:endParaRPr lang="en-US" sz="2800" dirty="0"/>
-          </a:p>
-        </p:txBody>
-      </p:sp>
-      <p:sp>
-        <p:nvSpPr>
-          <p:cNvPr id="4" name="Shape 2"/>
+            <a:endParaRPr lang="en-US" sz="2600" dirty="0"/>
+          </a:p>
+        </p:txBody>
+      </p:sp>
+      <p:sp>
+        <p:nvSpPr>
+          <p:cNvPr id="4" name="Text 2"/>
+          <p:cNvSpPr/>
+          <p:nvPr/>
+        </p:nvSpPr>
+        <p:spPr>
+          <a:xfrm>
+            <a:off x="548640" y="1298448"/>
+            <a:ext cx="10058400" cy="256032"/>
+          </a:xfrm>
+          <a:prstGeom prst="rect">
+            <a:avLst/>
+          </a:prstGeom>
+          <a:noFill/>
+          <a:ln/>
+        </p:spPr>
+        <p:txBody>
+          <a:bodyPr wrap="square" lIns="0" tIns="0" rIns="0" bIns="0" rtlCol="0" anchor="ctr"/>
+          <a:lstStyle/>
+          <a:p>
+            <a:pPr indent="0" marL="0">
+              <a:buNone/>
+            </a:pPr>
+            <a:r>
+              <a:rPr lang="en-US" sz="1100" i="1" dirty="0">
+                <a:solidFill>
+                  <a:srgbClr val="8B9CB0"/>
+                </a:solidFill>
+                <a:latin typeface="Arial" pitchFamily="34" charset="0"/>
+                <a:ea typeface="Arial" pitchFamily="34" charset="-122"/>
+                <a:cs typeface="Arial" pitchFamily="34" charset="-120"/>
+              </a:rPr>
+              <a:t>Gambar diblur — data internal bersifat rahasia perusahaan.</a:t>
+            </a:r>
+            <a:endParaRPr lang="en-US" sz="1100" dirty="0"/>
+          </a:p>
+        </p:txBody>
+      </p:sp>
+      <p:sp>
+        <p:nvSpPr>
+          <p:cNvPr id="5" name="Shape 3"/>
           <p:cNvSpPr/>
           <p:nvPr/>
         </p:nvSpPr>
@@ -8040,7 +8079,7 @@
       </p:sp>
       <p:pic>
         <p:nvPicPr>
-          <p:cNvPr id="5" name="Image 0" descr="/sessions/laughing-amazing-bohr/mnt/webportomaganghub/dashboard-revenue.png">    </p:cNvPr>
+          <p:cNvPr id="6" name="Image 0" descr="/sessions/laughing-amazing-bohr/mnt/webportomaganghub/dashboard-revenue.jpg">    </p:cNvPr>
           <p:cNvPicPr>
             <a:picLocks noChangeAspect="1"/>
           </p:cNvPicPr>
@@ -8063,7 +8102,7 @@
       </p:pic>
       <p:sp>
         <p:nvSpPr>
-          <p:cNvPr id="6" name="Text 3"/>
+          <p:cNvPr id="7" name="Text 4"/>
           <p:cNvSpPr/>
           <p:nvPr/>
         </p:nvSpPr>
@@ -8102,7 +8141,7 @@
       </p:sp>
       <p:sp>
         <p:nvSpPr>
-          <p:cNvPr id="7" name="Text 4"/>
+          <p:cNvPr id="8" name="Text 5"/>
           <p:cNvSpPr/>
           <p:nvPr/>
         </p:nvSpPr>
@@ -8133,7 +8172,7 @@
                 <a:ea typeface="Courier New" pitchFamily="34" charset="-122"/>
                 <a:cs typeface="Courier New" pitchFamily="34" charset="-120"/>
               </a:rPr>
-              <a:t>Net Revenue 24.68bn · 199.76K user · 2.68bn transaksi</a:t>
+              <a:t>Monitoring revenue &amp; transaksi · metode bayar · provider</a:t>
             </a:r>
             <a:endParaRPr lang="en-US" sz="900" dirty="0"/>
           </a:p>
@@ -8141,7 +8180,7 @@
       </p:sp>
       <p:sp>
         <p:nvSpPr>
-          <p:cNvPr id="8" name="Shape 5"/>
+          <p:cNvPr id="9" name="Shape 6"/>
           <p:cNvSpPr/>
           <p:nvPr/>
         </p:nvSpPr>
@@ -8175,7 +8214,7 @@
       </p:sp>
       <p:pic>
         <p:nvPicPr>
-          <p:cNvPr id="9" name="Image 1" descr="/sessions/laughing-amazing-bohr/mnt/webportomaganghub/dashboard-user.png">    </p:cNvPr>
+          <p:cNvPr id="10" name="Image 1" descr="/sessions/laughing-amazing-bohr/mnt/webportomaganghub/dashboard-user.jpg">    </p:cNvPr>
           <p:cNvPicPr>
             <a:picLocks noChangeAspect="1"/>
           </p:cNvPicPr>
@@ -8198,7 +8237,7 @@
       </p:pic>
       <p:sp>
         <p:nvSpPr>
-          <p:cNvPr id="10" name="Text 6"/>
+          <p:cNvPr id="11" name="Text 7"/>
           <p:cNvSpPr/>
           <p:nvPr/>
         </p:nvSpPr>
@@ -8237,7 +8276,7 @@
       </p:sp>
       <p:sp>
         <p:nvSpPr>
-          <p:cNvPr id="11" name="Text 7"/>
+          <p:cNvPr id="12" name="Text 8"/>
           <p:cNvSpPr/>
           <p:nvPr/>
         </p:nvSpPr>
@@ -8268,7 +8307,7 @@
                 <a:ea typeface="Courier New" pitchFamily="34" charset="-122"/>
                 <a:cs typeface="Courier New" pitchFamily="34" charset="-120"/>
               </a:rPr>
-              <a:t>914.48K user · conversion 17.6% · segmentasi platform</a:t>
+              <a:t>Segmentasi platform · demografi · conversion</a:t>
             </a:r>
             <a:endParaRPr lang="en-US" sz="900" dirty="0"/>
           </a:p>
@@ -8276,7 +8315,7 @@
       </p:sp>
       <p:sp>
         <p:nvSpPr>
-          <p:cNvPr id="12" name="Shape 8"/>
+          <p:cNvPr id="13" name="Shape 9"/>
           <p:cNvSpPr/>
           <p:nvPr/>
         </p:nvSpPr>
@@ -8310,7 +8349,7 @@
       </p:sp>
       <p:pic>
         <p:nvPicPr>
-          <p:cNvPr id="13" name="Image 2" descr="/sessions/laughing-amazing-bohr/mnt/webportomaganghub/dashboard-package.png">    </p:cNvPr>
+          <p:cNvPr id="14" name="Image 2" descr="/sessions/laughing-amazing-bohr/mnt/webportomaganghub/dashboard-package.jpg">    </p:cNvPr>
           <p:cNvPicPr>
             <a:picLocks noChangeAspect="1"/>
           </p:cNvPicPr>
@@ -8333,7 +8372,7 @@
       </p:pic>
       <p:sp>
         <p:nvSpPr>
-          <p:cNvPr id="14" name="Text 9"/>
+          <p:cNvPr id="15" name="Text 10"/>
           <p:cNvSpPr/>
           <p:nvPr/>
         </p:nvSpPr>
@@ -8372,7 +8411,7 @@
       </p:sp>
       <p:sp>
         <p:nvSpPr>
-          <p:cNvPr id="15" name="Text 10"/>
+          <p:cNvPr id="16" name="Text 11"/>
           <p:cNvSpPr/>
           <p:nvPr/>
         </p:nvSpPr>
@@ -8403,7 +8442,7 @@
                 <a:ea typeface="Courier New" pitchFamily="34" charset="-122"/>
                 <a:cs typeface="Courier New" pitchFamily="34" charset="-120"/>
               </a:rPr>
-              <a:t>Harga &amp; diskon per price-segment · avg price · ARPU</a:t>
+              <a:t>Struktur harga &amp; diskon paket · ringkasan per segmen</a:t>
             </a:r>
             <a:endParaRPr lang="en-US" sz="900" dirty="0"/>
           </a:p>
@@ -8411,7 +8450,7 @@
       </p:sp>
       <p:sp>
         <p:nvSpPr>
-          <p:cNvPr id="16" name="Shape 11"/>
+          <p:cNvPr id="17" name="Shape 12"/>
           <p:cNvSpPr/>
           <p:nvPr/>
         </p:nvSpPr>
@@ -8445,7 +8484,7 @@
       </p:sp>
       <p:pic>
         <p:nvPicPr>
-          <p:cNvPr id="17" name="Image 3" descr="/sessions/laughing-amazing-bohr/mnt/webportomaganghub/dashboard-activity.png">    </p:cNvPr>
+          <p:cNvPr id="18" name="Image 3" descr="/sessions/laughing-amazing-bohr/mnt/webportomaganghub/dashboard-activity.jpg">    </p:cNvPr>
           <p:cNvPicPr>
             <a:picLocks noChangeAspect="1"/>
           </p:cNvPicPr>
@@ -8468,7 +8507,7 @@
       </p:pic>
       <p:sp>
         <p:nvSpPr>
-          <p:cNvPr id="18" name="Text 12"/>
+          <p:cNvPr id="19" name="Text 13"/>
           <p:cNvSpPr/>
           <p:nvPr/>
         </p:nvSpPr>
@@ -8507,7 +8546,7 @@
       </p:sp>
       <p:sp>
         <p:nvSpPr>
-          <p:cNvPr id="19" name="Text 13"/>
+          <p:cNvPr id="20" name="Text 14"/>
           <p:cNvSpPr/>
           <p:nvPr/>
         </p:nvSpPr>
@@ -8546,7 +8585,7 @@
       </p:sp>
       <p:sp>
         <p:nvSpPr>
-          <p:cNvPr id="20" name="Text 14">
+          <p:cNvPr id="21" name="Text 15">
             <a:hlinkClick r:id="rId5" tooltip=""/>
           </p:cNvPr>
           <p:cNvSpPr/>
@@ -8594,7 +8633,7 @@
       </p:sp>
       <p:sp>
         <p:nvSpPr>
-          <p:cNvPr id="21" name="Text 15"/>
+          <p:cNvPr id="22" name="Text 16"/>
           <p:cNvSpPr/>
           <p:nvPr/>
         </p:nvSpPr>

</xml_diff>